<commit_message>
Update RACI matrix to bilingual Chinese-English version
</commit_message>
<xml_diff>
--- a/26090823_生产培训RACI矩阵完整.pptx
+++ b/26090823_生产培训RACI矩阵完整.pptx
@@ -190,7 +190,8 @@
                 <a:latin typeface="Microsoft YaHei"/>
                 <a:ea typeface="Microsoft YaHei"/>
               </a:rPr>
-              <a:t>生产培训管理体系 - RACI职责全景</a:t>
+              <a:t>生产培训管理体系 - RACI职责全景
+Production Training Management System - RACI Responsibility Overview</a:t>
             </a:r>
           </a:p>
         </p:txBody>
@@ -227,7 +228,7 @@
                 <a:latin typeface="Microsoft YaHei"/>
                 <a:ea typeface="Microsoft YaHei"/>
               </a:rPr>
-              <a:t>TM=集团培训经理 | TS=项目培训主管 | TR=一线培训师 | TC=培训文员 | HR=HR培训专员 | TL=生产班组长 | PM=项目经理 | MD=制造总监 | QA=质量部门</a:t>
+              <a:t>TM=集团培训经理(Training Manager) | TS=项目培训主管(Training Supervisor) | TR=一线培训师(Trainer) | TC=培训文员(Training Clerk) | HR=HR培训专员(HR Specialist) | TL=生产班组长(Team Leader) | PM=项目经理(Project Manager) | MD=制造总监(Manufacturing Director) | QA=质量部门(Quality Dept)</a:t>
             </a:r>
           </a:p>
         </p:txBody>
@@ -264,7 +265,7 @@
                 <a:latin typeface="Microsoft YaHei"/>
                 <a:ea typeface="Microsoft YaHei"/>
               </a:rPr>
-              <a:t>R=负责执行(绿)  A=最终审批(红)  C=被咨询(蓝)  I=被通知(灰)</a:t>
+              <a:t>R=负责执行/Responsible(Green)  A=最终审批/Accountable(Red)  C=被咨询/Consulted(Blue)  I=被通知/Informed(Gray)</a:t>
             </a:r>
           </a:p>
         </p:txBody>
@@ -301,7 +302,8 @@
                 <a:latin typeface="Microsoft YaHei"/>
                 <a:ea typeface="Microsoft YaHei"/>
               </a:rPr>
-              <a:t>基于RACI矩阵的10大模块 x 9类角色完整职责总览</a:t>
+              <a:t>基于RACI矩阵的10大模块 x 9类角色完整职责总览
+Complete Responsibility Overview: 10 Modules x 9 Roles based on RACI Matrix</a:t>
             </a:r>
           </a:p>
         </p:txBody>
@@ -354,7 +356,8 @@
       <a:r><a:rPr lang="zh-CN" sz="2400" b="1">
         <a:solidFill><a:srgbClr val="1B5E20"/></a:solidFill>
         <a:latin typeface="Microsoft YaHei"/><a:ea typeface="Microsoft YaHei"/>
-      </a:rPr><a:t>模块九：审核应对</a:t></a:r>
+      </a:rPr><a:t>模块九：审核应对
+Module 9: Audit Response</a:t></a:r>
     </a:p>
   </p:txBody>
 </p:sp>
@@ -372,7 +375,7 @@
       <a:r><a:rPr lang="zh-CN" sz="950">
         <a:solidFill><a:srgbClr val="2E7D32"/></a:solidFill>
         <a:latin typeface="Microsoft YaHei"/><a:ea typeface="Microsoft YaHei"/>
-      </a:rPr><a:t>TM=集团培训经理 | TS=项目培训主管 | TR=一线培训师 | TC=培训文员 | HR=HR培训专员 | TL=生产班组长 | PM=项目经理 | MD=制造总监 | QA=质量部门</a:t></a:r>
+      </a:rPr><a:t>TM=集团培训经理(Training Manager) | TS=项目培训主管(Training Supervisor) | TR=一线培训师(Trainer) | TC=培训文员(Training Clerk) | HR=HR培训专员(HR Specialist) | TL=生产班组长(Team Leader) | PM=项目经理(Project Manager) | MD=制造总监(Manufacturing Director) | QA=质量部门(Quality Dept)</a:t></a:r>
     </a:p>
   </p:txBody>
 </p:sp>
@@ -390,7 +393,7 @@
       <a:r><a:rPr lang="zh-CN" sz="900" b="1">
         <a:solidFill><a:srgbClr val="1B5E20"/></a:solidFill>
         <a:latin typeface="Microsoft YaHei"/><a:ea typeface="Microsoft YaHei"/>
-      </a:rPr><a:t>R=负责执行(绿)  A=最终审批(红)  C=被咨询(蓝)  I=被通知(灰)</a:t></a:r>
+      </a:rPr><a:t>R=负责执行/Responsible(Green)  A=最终审批/Accountable(Red)  C=被咨询/Consulted(Blue)  I=被通知/Informed(Gray)</a:t></a:r>
     </a:p>
   </p:txBody>
 </p:sp><p:graphicFrame>
@@ -434,7 +437,8 @@
           <a:latin typeface="Microsoft YaHei"/>
           <a:ea typeface="Microsoft YaHei"/>
         </a:rPr>
-        <a:t>#</a:t>
+        <a:t>#
+No.</a:t>
       </a:r>
     </a:p>
   </a:txBody>
@@ -454,7 +458,8 @@
           <a:latin typeface="Microsoft YaHei"/>
           <a:ea typeface="Microsoft YaHei"/>
         </a:rPr>
-        <a:t>流程环节</a:t>
+        <a:t>流程环节
+Process Step</a:t>
       </a:r>
     </a:p>
   </a:txBody>
@@ -474,7 +479,9 @@
           <a:latin typeface="Microsoft YaHei"/>
           <a:ea typeface="Microsoft YaHei"/>
         </a:rPr>
-        <a:t>TM</a:t>
+        <a:t>TM
+Training
+Manager</a:t>
       </a:r>
     </a:p>
   </a:txBody>
@@ -494,7 +501,9 @@
           <a:latin typeface="Microsoft YaHei"/>
           <a:ea typeface="Microsoft YaHei"/>
         </a:rPr>
-        <a:t>TS</a:t>
+        <a:t>TS
+Training
+Supervisor</a:t>
       </a:r>
     </a:p>
   </a:txBody>
@@ -514,7 +523,8 @@
           <a:latin typeface="Microsoft YaHei"/>
           <a:ea typeface="Microsoft YaHei"/>
         </a:rPr>
-        <a:t>TR</a:t>
+        <a:t>TR
+Trainer</a:t>
       </a:r>
     </a:p>
   </a:txBody>
@@ -534,7 +544,9 @@
           <a:latin typeface="Microsoft YaHei"/>
           <a:ea typeface="Microsoft YaHei"/>
         </a:rPr>
-        <a:t>TC</a:t>
+        <a:t>TC
+Training
+Clerk</a:t>
       </a:r>
     </a:p>
   </a:txBody>
@@ -554,7 +566,9 @@
           <a:latin typeface="Microsoft YaHei"/>
           <a:ea typeface="Microsoft YaHei"/>
         </a:rPr>
-        <a:t>HR</a:t>
+        <a:t>HR
+HR
+Specialist</a:t>
       </a:r>
     </a:p>
   </a:txBody>
@@ -574,7 +588,9 @@
           <a:latin typeface="Microsoft YaHei"/>
           <a:ea typeface="Microsoft YaHei"/>
         </a:rPr>
-        <a:t>TL</a:t>
+        <a:t>TL
+Team
+Leader</a:t>
       </a:r>
     </a:p>
   </a:txBody>
@@ -594,7 +610,9 @@
           <a:latin typeface="Microsoft YaHei"/>
           <a:ea typeface="Microsoft YaHei"/>
         </a:rPr>
-        <a:t>PM</a:t>
+        <a:t>PM
+Project
+Manager</a:t>
       </a:r>
     </a:p>
   </a:txBody>
@@ -614,7 +632,9 @@
           <a:latin typeface="Microsoft YaHei"/>
           <a:ea typeface="Microsoft YaHei"/>
         </a:rPr>
-        <a:t>MD</a:t>
+        <a:t>MD
+Mfg
+Director</a:t>
       </a:r>
     </a:p>
   </a:txBody>
@@ -634,7 +654,9 @@
           <a:latin typeface="Microsoft YaHei"/>
           <a:ea typeface="Microsoft YaHei"/>
         </a:rPr>
-        <a:t>QA</a:t>
+        <a:t>QA
+Quality
+Dept</a:t>
       </a:r>
     </a:p>
   </a:txBody>
@@ -674,7 +696,8 @@
           <a:latin typeface="Microsoft YaHei"/>
           <a:ea typeface="Microsoft YaHei"/>
         </a:rPr>
-        <a:t>审核前培训资料准备</a:t>
+        <a:t>审核前培训资料准备
+Pre-audit Training Materials Preparation</a:t>
       </a:r>
     </a:p>
   </a:txBody>
@@ -894,7 +917,8 @@
           <a:latin typeface="Microsoft YaHei"/>
           <a:ea typeface="Microsoft YaHei"/>
         </a:rPr>
-        <a:t>审核中陪同与应答</a:t>
+        <a:t>审核中陪同与应答
+Audit Accompaniment &amp; Response</a:t>
       </a:r>
     </a:p>
   </a:txBody>
@@ -1114,7 +1138,8 @@
           <a:latin typeface="Microsoft YaHei"/>
           <a:ea typeface="Microsoft YaHei"/>
         </a:rPr>
-        <a:t>审核后不符合项整改计划</a:t>
+        <a:t>审核后不符合项整改计划
+Post-audit Non-conformity Corrective Action Plan</a:t>
       </a:r>
     </a:p>
   </a:txBody>
@@ -1334,7 +1359,8 @@
           <a:latin typeface="Microsoft YaHei"/>
           <a:ea typeface="Microsoft YaHei"/>
         </a:rPr>
-        <a:t>整改完成验证与证据提交</a:t>
+        <a:t>整改完成验证与证据提交
+Corrective Action Verification &amp; Evidence Submission</a:t>
       </a:r>
     </a:p>
   </a:txBody>
@@ -1554,7 +1580,8 @@
           <a:latin typeface="Microsoft YaHei"/>
           <a:ea typeface="Microsoft YaHei"/>
         </a:rPr>
-        <a:t>审核发现的内部分享与预防</a:t>
+        <a:t>审核发现的内部分享与预防
+Internal Sharing &amp; Prevention of Audit Findings</a:t>
       </a:r>
     </a:p>
   </a:txBody>
@@ -1793,7 +1820,8 @@
       <a:r><a:rPr lang="zh-CN" sz="2400" b="1">
         <a:solidFill><a:srgbClr val="1B5E20"/></a:solidFill>
         <a:latin typeface="Microsoft YaHei"/><a:ea typeface="Microsoft YaHei"/>
-      </a:rPr><a:t>模块十：持续改进</a:t></a:r>
+      </a:rPr><a:t>模块十：持续改进
+Module 10: Continuous Improvement</a:t></a:r>
     </a:p>
   </p:txBody>
 </p:sp>
@@ -1811,7 +1839,7 @@
       <a:r><a:rPr lang="zh-CN" sz="950">
         <a:solidFill><a:srgbClr val="2E7D32"/></a:solidFill>
         <a:latin typeface="Microsoft YaHei"/><a:ea typeface="Microsoft YaHei"/>
-      </a:rPr><a:t>TM=集团培训经理 | TS=项目培训主管 | TR=一线培训师 | TC=培训文员 | HR=HR培训专员 | TL=生产班组长 | PM=项目经理 | MD=制造总监 | QA=质量部门</a:t></a:r>
+      </a:rPr><a:t>TM=集团培训经理(Training Manager) | TS=项目培训主管(Training Supervisor) | TR=一线培训师(Trainer) | TC=培训文员(Training Clerk) | HR=HR培训专员(HR Specialist) | TL=生产班组长(Team Leader) | PM=项目经理(Project Manager) | MD=制造总监(Manufacturing Director) | QA=质量部门(Quality Dept)</a:t></a:r>
     </a:p>
   </p:txBody>
 </p:sp>
@@ -1829,7 +1857,7 @@
       <a:r><a:rPr lang="zh-CN" sz="900" b="1">
         <a:solidFill><a:srgbClr val="1B5E20"/></a:solidFill>
         <a:latin typeface="Microsoft YaHei"/><a:ea typeface="Microsoft YaHei"/>
-      </a:rPr><a:t>R=负责执行(绿)  A=最终审批(红)  C=被咨询(蓝)  I=被通知(灰)</a:t></a:r>
+      </a:rPr><a:t>R=负责执行/Responsible(Green)  A=最终审批/Accountable(Red)  C=被咨询/Consulted(Blue)  I=被通知/Informed(Gray)</a:t></a:r>
     </a:p>
   </p:txBody>
 </p:sp><p:graphicFrame>
@@ -1873,7 +1901,8 @@
           <a:latin typeface="Microsoft YaHei"/>
           <a:ea typeface="Microsoft YaHei"/>
         </a:rPr>
-        <a:t>#</a:t>
+        <a:t>#
+No.</a:t>
       </a:r>
     </a:p>
   </a:txBody>
@@ -1893,7 +1922,8 @@
           <a:latin typeface="Microsoft YaHei"/>
           <a:ea typeface="Microsoft YaHei"/>
         </a:rPr>
-        <a:t>流程环节</a:t>
+        <a:t>流程环节
+Process Step</a:t>
       </a:r>
     </a:p>
   </a:txBody>
@@ -1913,7 +1943,9 @@
           <a:latin typeface="Microsoft YaHei"/>
           <a:ea typeface="Microsoft YaHei"/>
         </a:rPr>
-        <a:t>TM</a:t>
+        <a:t>TM
+Training
+Manager</a:t>
       </a:r>
     </a:p>
   </a:txBody>
@@ -1933,7 +1965,9 @@
           <a:latin typeface="Microsoft YaHei"/>
           <a:ea typeface="Microsoft YaHei"/>
         </a:rPr>
-        <a:t>TS</a:t>
+        <a:t>TS
+Training
+Supervisor</a:t>
       </a:r>
     </a:p>
   </a:txBody>
@@ -1953,7 +1987,8 @@
           <a:latin typeface="Microsoft YaHei"/>
           <a:ea typeface="Microsoft YaHei"/>
         </a:rPr>
-        <a:t>TR</a:t>
+        <a:t>TR
+Trainer</a:t>
       </a:r>
     </a:p>
   </a:txBody>
@@ -1973,7 +2008,9 @@
           <a:latin typeface="Microsoft YaHei"/>
           <a:ea typeface="Microsoft YaHei"/>
         </a:rPr>
-        <a:t>TC</a:t>
+        <a:t>TC
+Training
+Clerk</a:t>
       </a:r>
     </a:p>
   </a:txBody>
@@ -1993,7 +2030,9 @@
           <a:latin typeface="Microsoft YaHei"/>
           <a:ea typeface="Microsoft YaHei"/>
         </a:rPr>
-        <a:t>HR</a:t>
+        <a:t>HR
+HR
+Specialist</a:t>
       </a:r>
     </a:p>
   </a:txBody>
@@ -2013,7 +2052,9 @@
           <a:latin typeface="Microsoft YaHei"/>
           <a:ea typeface="Microsoft YaHei"/>
         </a:rPr>
-        <a:t>TL</a:t>
+        <a:t>TL
+Team
+Leader</a:t>
       </a:r>
     </a:p>
   </a:txBody>
@@ -2033,7 +2074,9 @@
           <a:latin typeface="Microsoft YaHei"/>
           <a:ea typeface="Microsoft YaHei"/>
         </a:rPr>
-        <a:t>PM</a:t>
+        <a:t>PM
+Project
+Manager</a:t>
       </a:r>
     </a:p>
   </a:txBody>
@@ -2053,7 +2096,9 @@
           <a:latin typeface="Microsoft YaHei"/>
           <a:ea typeface="Microsoft YaHei"/>
         </a:rPr>
-        <a:t>MD</a:t>
+        <a:t>MD
+Mfg
+Director</a:t>
       </a:r>
     </a:p>
   </a:txBody>
@@ -2073,7 +2118,9 @@
           <a:latin typeface="Microsoft YaHei"/>
           <a:ea typeface="Microsoft YaHei"/>
         </a:rPr>
-        <a:t>QA</a:t>
+        <a:t>QA
+Quality
+Dept</a:t>
       </a:r>
     </a:p>
   </a:txBody>
@@ -2113,7 +2160,8 @@
           <a:latin typeface="Microsoft YaHei"/>
           <a:ea typeface="Microsoft YaHei"/>
         </a:rPr>
-        <a:t>培训效果评估(Kirkpatrick)</a:t>
+        <a:t>培训效果评估(Kirkpatrick)
+Training Effectiveness Evaluation (Kirkpatrick)</a:t>
       </a:r>
     </a:p>
   </a:txBody>
@@ -2333,7 +2381,8 @@
           <a:latin typeface="Microsoft YaHei"/>
           <a:ea typeface="Microsoft YaHei"/>
         </a:rPr>
-        <a:t>培训体系月度复盘</a:t>
+        <a:t>培训体系月度复盘
+Training System Monthly Review</a:t>
       </a:r>
     </a:p>
   </a:txBody>
@@ -2553,7 +2602,8 @@
           <a:latin typeface="Microsoft YaHei"/>
           <a:ea typeface="Microsoft YaHei"/>
         </a:rPr>
-        <a:t>培训课程/教材更新迭代</a:t>
+        <a:t>培训课程/教材更新迭代
+Training Course/Material Update &amp; Iteration</a:t>
       </a:r>
     </a:p>
   </a:txBody>
@@ -2773,7 +2823,8 @@
           <a:latin typeface="Microsoft YaHei"/>
           <a:ea typeface="Microsoft YaHei"/>
         </a:rPr>
-        <a:t>培训创新/改进建议收集</a:t>
+        <a:t>培训创新/改进建议收集
+Training Innovation/Improvement Suggestions Collection</a:t>
       </a:r>
     </a:p>
   </a:txBody>
@@ -2993,7 +3044,8 @@
           <a:latin typeface="Microsoft YaHei"/>
           <a:ea typeface="Microsoft YaHei"/>
         </a:rPr>
-        <a:t>最佳实践跨项目推广</a:t>
+        <a:t>最佳实践跨项目推广
+Best Practice Cross-project Promotion</a:t>
       </a:r>
     </a:p>
   </a:txBody>
@@ -3232,7 +3284,8 @@
       <a:r><a:rPr lang="zh-CN" sz="2400" b="1">
         <a:solidFill><a:srgbClr val="1B5E20"/></a:solidFill>
         <a:latin typeface="Microsoft YaHei"/><a:ea typeface="Microsoft YaHei"/>
-      </a:rPr><a:t>模块一：培训体系管理</a:t></a:r>
+      </a:rPr><a:t>模块一：培训体系管理
+Module 1: Training System Management</a:t></a:r>
     </a:p>
   </p:txBody>
 </p:sp>
@@ -3250,7 +3303,7 @@
       <a:r><a:rPr lang="zh-CN" sz="950">
         <a:solidFill><a:srgbClr val="2E7D32"/></a:solidFill>
         <a:latin typeface="Microsoft YaHei"/><a:ea typeface="Microsoft YaHei"/>
-      </a:rPr><a:t>TM=集团培训经理 | TS=项目培训主管 | TR=一线培训师 | TC=培训文员 | HR=HR培训专员 | TL=生产班组长 | PM=项目经理 | MD=制造总监 | QA=质量部门</a:t></a:r>
+      </a:rPr><a:t>TM=集团培训经理(Training Manager) | TS=项目培训主管(Training Supervisor) | TR=一线培训师(Trainer) | TC=培训文员(Training Clerk) | HR=HR培训专员(HR Specialist) | TL=生产班组长(Team Leader) | PM=项目经理(Project Manager) | MD=制造总监(Manufacturing Director) | QA=质量部门(Quality Dept)</a:t></a:r>
     </a:p>
   </p:txBody>
 </p:sp>
@@ -3268,7 +3321,7 @@
       <a:r><a:rPr lang="zh-CN" sz="900" b="1">
         <a:solidFill><a:srgbClr val="1B5E20"/></a:solidFill>
         <a:latin typeface="Microsoft YaHei"/><a:ea typeface="Microsoft YaHei"/>
-      </a:rPr><a:t>R=负责执行(绿)  A=最终审批(红)  C=被咨询(蓝)  I=被通知(灰)</a:t></a:r>
+      </a:rPr><a:t>R=负责执行/Responsible(Green)  A=最终审批/Accountable(Red)  C=被咨询/Consulted(Blue)  I=被通知/Informed(Gray)</a:t></a:r>
     </a:p>
   </p:txBody>
 </p:sp><p:graphicFrame>
@@ -3312,7 +3365,8 @@
           <a:latin typeface="Microsoft YaHei"/>
           <a:ea typeface="Microsoft YaHei"/>
         </a:rPr>
-        <a:t>#</a:t>
+        <a:t>#
+No.</a:t>
       </a:r>
     </a:p>
   </a:txBody>
@@ -3332,7 +3386,8 @@
           <a:latin typeface="Microsoft YaHei"/>
           <a:ea typeface="Microsoft YaHei"/>
         </a:rPr>
-        <a:t>流程环节</a:t>
+        <a:t>流程环节
+Process Step</a:t>
       </a:r>
     </a:p>
   </a:txBody>
@@ -3352,7 +3407,9 @@
           <a:latin typeface="Microsoft YaHei"/>
           <a:ea typeface="Microsoft YaHei"/>
         </a:rPr>
-        <a:t>TM</a:t>
+        <a:t>TM
+Training
+Manager</a:t>
       </a:r>
     </a:p>
   </a:txBody>
@@ -3372,7 +3429,9 @@
           <a:latin typeface="Microsoft YaHei"/>
           <a:ea typeface="Microsoft YaHei"/>
         </a:rPr>
-        <a:t>TS</a:t>
+        <a:t>TS
+Training
+Supervisor</a:t>
       </a:r>
     </a:p>
   </a:txBody>
@@ -3392,7 +3451,8 @@
           <a:latin typeface="Microsoft YaHei"/>
           <a:ea typeface="Microsoft YaHei"/>
         </a:rPr>
-        <a:t>TR</a:t>
+        <a:t>TR
+Trainer</a:t>
       </a:r>
     </a:p>
   </a:txBody>
@@ -3412,7 +3472,9 @@
           <a:latin typeface="Microsoft YaHei"/>
           <a:ea typeface="Microsoft YaHei"/>
         </a:rPr>
-        <a:t>TC</a:t>
+        <a:t>TC
+Training
+Clerk</a:t>
       </a:r>
     </a:p>
   </a:txBody>
@@ -3432,7 +3494,9 @@
           <a:latin typeface="Microsoft YaHei"/>
           <a:ea typeface="Microsoft YaHei"/>
         </a:rPr>
-        <a:t>HR</a:t>
+        <a:t>HR
+HR
+Specialist</a:t>
       </a:r>
     </a:p>
   </a:txBody>
@@ -3452,7 +3516,9 @@
           <a:latin typeface="Microsoft YaHei"/>
           <a:ea typeface="Microsoft YaHei"/>
         </a:rPr>
-        <a:t>TL</a:t>
+        <a:t>TL
+Team
+Leader</a:t>
       </a:r>
     </a:p>
   </a:txBody>
@@ -3472,7 +3538,9 @@
           <a:latin typeface="Microsoft YaHei"/>
           <a:ea typeface="Microsoft YaHei"/>
         </a:rPr>
-        <a:t>PM</a:t>
+        <a:t>PM
+Project
+Manager</a:t>
       </a:r>
     </a:p>
   </a:txBody>
@@ -3492,7 +3560,9 @@
           <a:latin typeface="Microsoft YaHei"/>
           <a:ea typeface="Microsoft YaHei"/>
         </a:rPr>
-        <a:t>MD</a:t>
+        <a:t>MD
+Mfg
+Director</a:t>
       </a:r>
     </a:p>
   </a:txBody>
@@ -3512,7 +3582,9 @@
           <a:latin typeface="Microsoft YaHei"/>
           <a:ea typeface="Microsoft YaHei"/>
         </a:rPr>
-        <a:t>QA</a:t>
+        <a:t>QA
+Quality
+Dept</a:t>
       </a:r>
     </a:p>
   </a:txBody>
@@ -3552,7 +3624,8 @@
           <a:latin typeface="Microsoft YaHei"/>
           <a:ea typeface="Microsoft YaHei"/>
         </a:rPr>
-        <a:t>培训组织架构设计与审批</a:t>
+        <a:t>培训组织架构设计与审批
+Training Org Structure Design &amp; Approval</a:t>
       </a:r>
     </a:p>
   </a:txBody>
@@ -3772,7 +3845,8 @@
           <a:latin typeface="Microsoft YaHei"/>
           <a:ea typeface="Microsoft YaHei"/>
         </a:rPr>
-        <a:t>培训管理制度/程序文件编制与更新</a:t>
+        <a:t>培训管理制度/程序文件编制与更新
+Training Policy/Procedure Document Creation &amp; Update</a:t>
       </a:r>
     </a:p>
   </a:txBody>
@@ -3992,7 +4066,8 @@
           <a:latin typeface="Microsoft YaHei"/>
           <a:ea typeface="Microsoft YaHei"/>
         </a:rPr>
-        <a:t>培训政策宣贯与沟通</a:t>
+        <a:t>培训政策宣贯与沟通
+Training Policy Communication &amp; Rollout</a:t>
       </a:r>
     </a:p>
   </a:txBody>
@@ -4231,7 +4306,8 @@
       <a:r><a:rPr lang="zh-CN" sz="2400" b="1">
         <a:solidFill><a:srgbClr val="1B5E20"/></a:solidFill>
         <a:latin typeface="Microsoft YaHei"/><a:ea typeface="Microsoft YaHei"/>
-      </a:rPr><a:t>模块二：培训需求管理</a:t></a:r>
+      </a:rPr><a:t>模块二：培训需求管理
+Module 2: Training Needs Management</a:t></a:r>
     </a:p>
   </p:txBody>
 </p:sp>
@@ -4249,7 +4325,7 @@
       <a:r><a:rPr lang="zh-CN" sz="950">
         <a:solidFill><a:srgbClr val="2E7D32"/></a:solidFill>
         <a:latin typeface="Microsoft YaHei"/><a:ea typeface="Microsoft YaHei"/>
-      </a:rPr><a:t>TM=集团培训经理 | TS=项目培训主管 | TR=一线培训师 | TC=培训文员 | HR=HR培训专员 | TL=生产班组长 | PM=项目经理 | MD=制造总监 | QA=质量部门</a:t></a:r>
+      </a:rPr><a:t>TM=集团培训经理(Training Manager) | TS=项目培训主管(Training Supervisor) | TR=一线培训师(Trainer) | TC=培训文员(Training Clerk) | HR=HR培训专员(HR Specialist) | TL=生产班组长(Team Leader) | PM=项目经理(Project Manager) | MD=制造总监(Manufacturing Director) | QA=质量部门(Quality Dept)</a:t></a:r>
     </a:p>
   </p:txBody>
 </p:sp>
@@ -4267,7 +4343,7 @@
       <a:r><a:rPr lang="zh-CN" sz="900" b="1">
         <a:solidFill><a:srgbClr val="1B5E20"/></a:solidFill>
         <a:latin typeface="Microsoft YaHei"/><a:ea typeface="Microsoft YaHei"/>
-      </a:rPr><a:t>R=负责执行(绿)  A=最终审批(红)  C=被咨询(蓝)  I=被通知(灰)</a:t></a:r>
+      </a:rPr><a:t>R=负责执行/Responsible(Green)  A=最终审批/Accountable(Red)  C=被咨询/Consulted(Blue)  I=被通知/Informed(Gray)</a:t></a:r>
     </a:p>
   </p:txBody>
 </p:sp><p:graphicFrame>
@@ -4311,7 +4387,8 @@
           <a:latin typeface="Microsoft YaHei"/>
           <a:ea typeface="Microsoft YaHei"/>
         </a:rPr>
-        <a:t>#</a:t>
+        <a:t>#
+No.</a:t>
       </a:r>
     </a:p>
   </a:txBody>
@@ -4331,7 +4408,8 @@
           <a:latin typeface="Microsoft YaHei"/>
           <a:ea typeface="Microsoft YaHei"/>
         </a:rPr>
-        <a:t>流程环节</a:t>
+        <a:t>流程环节
+Process Step</a:t>
       </a:r>
     </a:p>
   </a:txBody>
@@ -4351,7 +4429,9 @@
           <a:latin typeface="Microsoft YaHei"/>
           <a:ea typeface="Microsoft YaHei"/>
         </a:rPr>
-        <a:t>TM</a:t>
+        <a:t>TM
+Training
+Manager</a:t>
       </a:r>
     </a:p>
   </a:txBody>
@@ -4371,7 +4451,9 @@
           <a:latin typeface="Microsoft YaHei"/>
           <a:ea typeface="Microsoft YaHei"/>
         </a:rPr>
-        <a:t>TS</a:t>
+        <a:t>TS
+Training
+Supervisor</a:t>
       </a:r>
     </a:p>
   </a:txBody>
@@ -4391,7 +4473,8 @@
           <a:latin typeface="Microsoft YaHei"/>
           <a:ea typeface="Microsoft YaHei"/>
         </a:rPr>
-        <a:t>TR</a:t>
+        <a:t>TR
+Trainer</a:t>
       </a:r>
     </a:p>
   </a:txBody>
@@ -4411,7 +4494,9 @@
           <a:latin typeface="Microsoft YaHei"/>
           <a:ea typeface="Microsoft YaHei"/>
         </a:rPr>
-        <a:t>TC</a:t>
+        <a:t>TC
+Training
+Clerk</a:t>
       </a:r>
     </a:p>
   </a:txBody>
@@ -4431,7 +4516,9 @@
           <a:latin typeface="Microsoft YaHei"/>
           <a:ea typeface="Microsoft YaHei"/>
         </a:rPr>
-        <a:t>HR</a:t>
+        <a:t>HR
+HR
+Specialist</a:t>
       </a:r>
     </a:p>
   </a:txBody>
@@ -4451,7 +4538,9 @@
           <a:latin typeface="Microsoft YaHei"/>
           <a:ea typeface="Microsoft YaHei"/>
         </a:rPr>
-        <a:t>TL</a:t>
+        <a:t>TL
+Team
+Leader</a:t>
       </a:r>
     </a:p>
   </a:txBody>
@@ -4471,7 +4560,9 @@
           <a:latin typeface="Microsoft YaHei"/>
           <a:ea typeface="Microsoft YaHei"/>
         </a:rPr>
-        <a:t>PM</a:t>
+        <a:t>PM
+Project
+Manager</a:t>
       </a:r>
     </a:p>
   </a:txBody>
@@ -4491,7 +4582,9 @@
           <a:latin typeface="Microsoft YaHei"/>
           <a:ea typeface="Microsoft YaHei"/>
         </a:rPr>
-        <a:t>MD</a:t>
+        <a:t>MD
+Mfg
+Director</a:t>
       </a:r>
     </a:p>
   </a:txBody>
@@ -4511,7 +4604,9 @@
           <a:latin typeface="Microsoft YaHei"/>
           <a:ea typeface="Microsoft YaHei"/>
         </a:rPr>
-        <a:t>QA</a:t>
+        <a:t>QA
+Quality
+Dept</a:t>
       </a:r>
     </a:p>
   </a:txBody>
@@ -4551,7 +4646,8 @@
           <a:latin typeface="Microsoft YaHei"/>
           <a:ea typeface="Microsoft YaHei"/>
         </a:rPr>
-        <a:t>新员工入职培训需求确认</a:t>
+        <a:t>新员工入职培训需求确认
+New Employee Onboarding Training Needs Confirmation</a:t>
       </a:r>
     </a:p>
   </a:txBody>
@@ -4771,7 +4867,8 @@
           <a:latin typeface="Microsoft YaHei"/>
           <a:ea typeface="Microsoft YaHei"/>
         </a:rPr>
-        <a:t>在岗员工技能差距分析</a:t>
+        <a:t>在岗员工技能差距分析
+On-job Employee Skill Gap Analysis</a:t>
       </a:r>
     </a:p>
   </a:txBody>
@@ -4991,7 +5088,8 @@
           <a:latin typeface="Microsoft YaHei"/>
           <a:ea typeface="Microsoft YaHei"/>
         </a:rPr>
-        <a:t>转岗/调岗培训需求确认</a:t>
+        <a:t>转岗/调岗培训需求确认
+Transfer/Reassignment Training Needs Confirmation</a:t>
       </a:r>
     </a:p>
   </a:txBody>
@@ -5211,7 +5309,8 @@
           <a:latin typeface="Microsoft YaHei"/>
           <a:ea typeface="Microsoft YaHei"/>
         </a:rPr>
-        <a:t>返岗培训需求确认</a:t>
+        <a:t>返岗培训需求确认
+Return-to-work Training Needs Confirmation</a:t>
       </a:r>
     </a:p>
   </a:txBody>
@@ -5431,7 +5530,8 @@
           <a:latin typeface="Microsoft YaHei"/>
           <a:ea typeface="Microsoft YaHei"/>
         </a:rPr>
-        <a:t>质量/安全问题触发的专项培训需求</a:t>
+        <a:t>质量/安全问题触发的专项培训需求
+Quality/Safety Issue-triggered Special Training Needs</a:t>
       </a:r>
     </a:p>
   </a:txBody>
@@ -5651,7 +5751,8 @@
           <a:latin typeface="Microsoft YaHei"/>
           <a:ea typeface="Microsoft YaHei"/>
         </a:rPr>
-        <a:t>客户审核/验厂触发的培训需求</a:t>
+        <a:t>客户审核/验厂触发的培训需求
+Customer Audit/Inspection-triggered Training Needs</a:t>
       </a:r>
     </a:p>
   </a:txBody>
@@ -5890,7 +5991,8 @@
       <a:r><a:rPr lang="zh-CN" sz="2400" b="1">
         <a:solidFill><a:srgbClr val="1B5E20"/></a:solidFill>
         <a:latin typeface="Microsoft YaHei"/><a:ea typeface="Microsoft YaHei"/>
-      </a:rPr><a:t>模块三：培训计划管理</a:t></a:r>
+      </a:rPr><a:t>模块三：培训计划管理
+Module 3: Training Plan Management</a:t></a:r>
     </a:p>
   </p:txBody>
 </p:sp>
@@ -5908,7 +6010,7 @@
       <a:r><a:rPr lang="zh-CN" sz="950">
         <a:solidFill><a:srgbClr val="2E7D32"/></a:solidFill>
         <a:latin typeface="Microsoft YaHei"/><a:ea typeface="Microsoft YaHei"/>
-      </a:rPr><a:t>TM=集团培训经理 | TS=项目培训主管 | TR=一线培训师 | TC=培训文员 | HR=HR培训专员 | TL=生产班组长 | PM=项目经理 | MD=制造总监 | QA=质量部门</a:t></a:r>
+      </a:rPr><a:t>TM=集团培训经理(Training Manager) | TS=项目培训主管(Training Supervisor) | TR=一线培训师(Trainer) | TC=培训文员(Training Clerk) | HR=HR培训专员(HR Specialist) | TL=生产班组长(Team Leader) | PM=项目经理(Project Manager) | MD=制造总监(Manufacturing Director) | QA=质量部门(Quality Dept)</a:t></a:r>
     </a:p>
   </p:txBody>
 </p:sp>
@@ -5926,7 +6028,7 @@
       <a:r><a:rPr lang="zh-CN" sz="900" b="1">
         <a:solidFill><a:srgbClr val="1B5E20"/></a:solidFill>
         <a:latin typeface="Microsoft YaHei"/><a:ea typeface="Microsoft YaHei"/>
-      </a:rPr><a:t>R=负责执行(绿)  A=最终审批(红)  C=被咨询(蓝)  I=被通知(灰)</a:t></a:r>
+      </a:rPr><a:t>R=负责执行/Responsible(Green)  A=最终审批/Accountable(Red)  C=被咨询/Consulted(Blue)  I=被通知/Informed(Gray)</a:t></a:r>
     </a:p>
   </p:txBody>
 </p:sp><p:graphicFrame>
@@ -5970,7 +6072,8 @@
           <a:latin typeface="Microsoft YaHei"/>
           <a:ea typeface="Microsoft YaHei"/>
         </a:rPr>
-        <a:t>#</a:t>
+        <a:t>#
+No.</a:t>
       </a:r>
     </a:p>
   </a:txBody>
@@ -5990,7 +6093,8 @@
           <a:latin typeface="Microsoft YaHei"/>
           <a:ea typeface="Microsoft YaHei"/>
         </a:rPr>
-        <a:t>流程环节</a:t>
+        <a:t>流程环节
+Process Step</a:t>
       </a:r>
     </a:p>
   </a:txBody>
@@ -6010,7 +6114,9 @@
           <a:latin typeface="Microsoft YaHei"/>
           <a:ea typeface="Microsoft YaHei"/>
         </a:rPr>
-        <a:t>TM</a:t>
+        <a:t>TM
+Training
+Manager</a:t>
       </a:r>
     </a:p>
   </a:txBody>
@@ -6030,7 +6136,9 @@
           <a:latin typeface="Microsoft YaHei"/>
           <a:ea typeface="Microsoft YaHei"/>
         </a:rPr>
-        <a:t>TS</a:t>
+        <a:t>TS
+Training
+Supervisor</a:t>
       </a:r>
     </a:p>
   </a:txBody>
@@ -6050,7 +6158,8 @@
           <a:latin typeface="Microsoft YaHei"/>
           <a:ea typeface="Microsoft YaHei"/>
         </a:rPr>
-        <a:t>TR</a:t>
+        <a:t>TR
+Trainer</a:t>
       </a:r>
     </a:p>
   </a:txBody>
@@ -6070,7 +6179,9 @@
           <a:latin typeface="Microsoft YaHei"/>
           <a:ea typeface="Microsoft YaHei"/>
         </a:rPr>
-        <a:t>TC</a:t>
+        <a:t>TC
+Training
+Clerk</a:t>
       </a:r>
     </a:p>
   </a:txBody>
@@ -6090,7 +6201,9 @@
           <a:latin typeface="Microsoft YaHei"/>
           <a:ea typeface="Microsoft YaHei"/>
         </a:rPr>
-        <a:t>HR</a:t>
+        <a:t>HR
+HR
+Specialist</a:t>
       </a:r>
     </a:p>
   </a:txBody>
@@ -6110,7 +6223,9 @@
           <a:latin typeface="Microsoft YaHei"/>
           <a:ea typeface="Microsoft YaHei"/>
         </a:rPr>
-        <a:t>TL</a:t>
+        <a:t>TL
+Team
+Leader</a:t>
       </a:r>
     </a:p>
   </a:txBody>
@@ -6130,7 +6245,9 @@
           <a:latin typeface="Microsoft YaHei"/>
           <a:ea typeface="Microsoft YaHei"/>
         </a:rPr>
-        <a:t>PM</a:t>
+        <a:t>PM
+Project
+Manager</a:t>
       </a:r>
     </a:p>
   </a:txBody>
@@ -6150,7 +6267,9 @@
           <a:latin typeface="Microsoft YaHei"/>
           <a:ea typeface="Microsoft YaHei"/>
         </a:rPr>
-        <a:t>MD</a:t>
+        <a:t>MD
+Mfg
+Director</a:t>
       </a:r>
     </a:p>
   </a:txBody>
@@ -6170,7 +6289,9 @@
           <a:latin typeface="Microsoft YaHei"/>
           <a:ea typeface="Microsoft YaHei"/>
         </a:rPr>
-        <a:t>QA</a:t>
+        <a:t>QA
+Quality
+Dept</a:t>
       </a:r>
     </a:p>
   </a:txBody>
@@ -6210,7 +6331,8 @@
           <a:latin typeface="Microsoft YaHei"/>
           <a:ea typeface="Microsoft YaHei"/>
         </a:rPr>
-        <a:t>年度培训计划编制</a:t>
+        <a:t>年度培训计划编制
+Annual Training Plan Development</a:t>
       </a:r>
     </a:p>
   </a:txBody>
@@ -6430,7 +6552,8 @@
           <a:latin typeface="Microsoft YaHei"/>
           <a:ea typeface="Microsoft YaHei"/>
         </a:rPr>
-        <a:t>月度培训计划分解</a:t>
+        <a:t>月度培训计划分解
+Monthly Training Plan Breakdown</a:t>
       </a:r>
     </a:p>
   </a:txBody>
@@ -6650,7 +6773,8 @@
           <a:latin typeface="Microsoft YaHei"/>
           <a:ea typeface="Microsoft YaHei"/>
         </a:rPr>
-        <a:t>周度培训计划排期</a:t>
+        <a:t>周度培训计划排期
+Weekly Training Plan Scheduling</a:t>
       </a:r>
     </a:p>
   </a:txBody>
@@ -6870,7 +6994,8 @@
           <a:latin typeface="Microsoft YaHei"/>
           <a:ea typeface="Microsoft YaHei"/>
         </a:rPr>
-        <a:t>临时/紧急培训计划安排</a:t>
+        <a:t>临时/紧急培训计划安排
+Temporary/Emergency Training Plan Arrangement</a:t>
       </a:r>
     </a:p>
   </a:txBody>
@@ -7090,7 +7215,8 @@
           <a:latin typeface="Microsoft YaHei"/>
           <a:ea typeface="Microsoft YaHei"/>
         </a:rPr>
-        <a:t>培训计划变更申请与审批</a:t>
+        <a:t>培训计划变更申请与审批
+Training Plan Change Request &amp; Approval</a:t>
       </a:r>
     </a:p>
   </a:txBody>
@@ -7329,7 +7455,8 @@
       <a:r><a:rPr lang="zh-CN" sz="2400" b="1">
         <a:solidFill><a:srgbClr val="1B5E20"/></a:solidFill>
         <a:latin typeface="Microsoft YaHei"/><a:ea typeface="Microsoft YaHei"/>
-      </a:rPr><a:t>模块四：培训实施</a:t></a:r>
+      </a:rPr><a:t>模块四：培训实施
+Module 4: Training Implementation</a:t></a:r>
     </a:p>
   </p:txBody>
 </p:sp>
@@ -7347,7 +7474,7 @@
       <a:r><a:rPr lang="zh-CN" sz="950">
         <a:solidFill><a:srgbClr val="2E7D32"/></a:solidFill>
         <a:latin typeface="Microsoft YaHei"/><a:ea typeface="Microsoft YaHei"/>
-      </a:rPr><a:t>TM=集团培训经理 | TS=项目培训主管 | TR=一线培训师 | TC=培训文员 | HR=HR培训专员 | TL=生产班组长 | PM=项目经理 | MD=制造总监 | QA=质量部门</a:t></a:r>
+      </a:rPr><a:t>TM=集团培训经理(Training Manager) | TS=项目培训主管(Training Supervisor) | TR=一线培训师(Trainer) | TC=培训文员(Training Clerk) | HR=HR培训专员(HR Specialist) | TL=生产班组长(Team Leader) | PM=项目经理(Project Manager) | MD=制造总监(Manufacturing Director) | QA=质量部门(Quality Dept)</a:t></a:r>
     </a:p>
   </p:txBody>
 </p:sp>
@@ -7365,7 +7492,7 @@
       <a:r><a:rPr lang="zh-CN" sz="900" b="1">
         <a:solidFill><a:srgbClr val="1B5E20"/></a:solidFill>
         <a:latin typeface="Microsoft YaHei"/><a:ea typeface="Microsoft YaHei"/>
-      </a:rPr><a:t>R=负责执行(绿)  A=最终审批(红)  C=被咨询(蓝)  I=被通知(灰)</a:t></a:r>
+      </a:rPr><a:t>R=负责执行/Responsible(Green)  A=最终审批/Accountable(Red)  C=被咨询/Consulted(Blue)  I=被通知/Informed(Gray)</a:t></a:r>
     </a:p>
   </p:txBody>
 </p:sp><p:graphicFrame>
@@ -7409,7 +7536,8 @@
           <a:latin typeface="Microsoft YaHei"/>
           <a:ea typeface="Microsoft YaHei"/>
         </a:rPr>
-        <a:t>#</a:t>
+        <a:t>#
+No.</a:t>
       </a:r>
     </a:p>
   </a:txBody>
@@ -7429,7 +7557,8 @@
           <a:latin typeface="Microsoft YaHei"/>
           <a:ea typeface="Microsoft YaHei"/>
         </a:rPr>
-        <a:t>流程环节</a:t>
+        <a:t>流程环节
+Process Step</a:t>
       </a:r>
     </a:p>
   </a:txBody>
@@ -7449,7 +7578,9 @@
           <a:latin typeface="Microsoft YaHei"/>
           <a:ea typeface="Microsoft YaHei"/>
         </a:rPr>
-        <a:t>TM</a:t>
+        <a:t>TM
+Training
+Manager</a:t>
       </a:r>
     </a:p>
   </a:txBody>
@@ -7469,7 +7600,9 @@
           <a:latin typeface="Microsoft YaHei"/>
           <a:ea typeface="Microsoft YaHei"/>
         </a:rPr>
-        <a:t>TS</a:t>
+        <a:t>TS
+Training
+Supervisor</a:t>
       </a:r>
     </a:p>
   </a:txBody>
@@ -7489,7 +7622,8 @@
           <a:latin typeface="Microsoft YaHei"/>
           <a:ea typeface="Microsoft YaHei"/>
         </a:rPr>
-        <a:t>TR</a:t>
+        <a:t>TR
+Trainer</a:t>
       </a:r>
     </a:p>
   </a:txBody>
@@ -7509,7 +7643,9 @@
           <a:latin typeface="Microsoft YaHei"/>
           <a:ea typeface="Microsoft YaHei"/>
         </a:rPr>
-        <a:t>TC</a:t>
+        <a:t>TC
+Training
+Clerk</a:t>
       </a:r>
     </a:p>
   </a:txBody>
@@ -7529,7 +7665,9 @@
           <a:latin typeface="Microsoft YaHei"/>
           <a:ea typeface="Microsoft YaHei"/>
         </a:rPr>
-        <a:t>HR</a:t>
+        <a:t>HR
+HR
+Specialist</a:t>
       </a:r>
     </a:p>
   </a:txBody>
@@ -7549,7 +7687,9 @@
           <a:latin typeface="Microsoft YaHei"/>
           <a:ea typeface="Microsoft YaHei"/>
         </a:rPr>
-        <a:t>TL</a:t>
+        <a:t>TL
+Team
+Leader</a:t>
       </a:r>
     </a:p>
   </a:txBody>
@@ -7569,7 +7709,9 @@
           <a:latin typeface="Microsoft YaHei"/>
           <a:ea typeface="Microsoft YaHei"/>
         </a:rPr>
-        <a:t>PM</a:t>
+        <a:t>PM
+Project
+Manager</a:t>
       </a:r>
     </a:p>
   </a:txBody>
@@ -7589,7 +7731,9 @@
           <a:latin typeface="Microsoft YaHei"/>
           <a:ea typeface="Microsoft YaHei"/>
         </a:rPr>
-        <a:t>MD</a:t>
+        <a:t>MD
+Mfg
+Director</a:t>
       </a:r>
     </a:p>
   </a:txBody>
@@ -7609,7 +7753,9 @@
           <a:latin typeface="Microsoft YaHei"/>
           <a:ea typeface="Microsoft YaHei"/>
         </a:rPr>
-        <a:t>QA</a:t>
+        <a:t>QA
+Quality
+Dept</a:t>
       </a:r>
     </a:p>
   </a:txBody>
@@ -7649,7 +7795,8 @@
           <a:latin typeface="Microsoft YaHei"/>
           <a:ea typeface="Microsoft YaHei"/>
         </a:rPr>
-        <a:t>新员工入职培训实施</a:t>
+        <a:t>新员工入职培训实施
+New Employee Onboarding Training Delivery</a:t>
       </a:r>
     </a:p>
   </a:txBody>
@@ -7869,7 +8016,8 @@
           <a:latin typeface="Microsoft YaHei"/>
           <a:ea typeface="Microsoft YaHei"/>
         </a:rPr>
-        <a:t>岗位理论培训实施</a:t>
+        <a:t>岗位理论培训实施
+Job Theory Training Delivery</a:t>
       </a:r>
     </a:p>
   </a:txBody>
@@ -8089,7 +8237,8 @@
           <a:latin typeface="Microsoft YaHei"/>
           <a:ea typeface="Microsoft YaHei"/>
         </a:rPr>
-        <a:t>岗位实操培训实施(OJT)</a:t>
+        <a:t>岗位实操培训实施(OJT)
+On-the-Job Practical Training (OJT)</a:t>
       </a:r>
     </a:p>
   </a:txBody>
@@ -8309,7 +8458,8 @@
           <a:latin typeface="Microsoft YaHei"/>
           <a:ea typeface="Microsoft YaHei"/>
         </a:rPr>
-        <a:t>班前会培训要点传达</a:t>
+        <a:t>班前会培训要点传达
+Pre-shift Meeting Training Key Points Delivery</a:t>
       </a:r>
     </a:p>
   </a:txBody>
@@ -8529,7 +8679,8 @@
           <a:latin typeface="Microsoft YaHei"/>
           <a:ea typeface="Microsoft YaHei"/>
         </a:rPr>
-        <a:t>专项培训实施</a:t>
+        <a:t>专项培训实施
+Special Training Delivery</a:t>
       </a:r>
     </a:p>
   </a:txBody>
@@ -8749,7 +8900,8 @@
           <a:latin typeface="Microsoft YaHei"/>
           <a:ea typeface="Microsoft YaHei"/>
         </a:rPr>
-        <a:t>转岗培训实施</a:t>
+        <a:t>转岗培训实施
+Transfer Training Delivery</a:t>
       </a:r>
     </a:p>
   </a:txBody>
@@ -8969,7 +9121,8 @@
           <a:latin typeface="Microsoft YaHei"/>
           <a:ea typeface="Microsoft YaHei"/>
         </a:rPr>
-        <a:t>培训签到与出勤记录</a:t>
+        <a:t>培训签到与出勤记录
+Training Sign-in &amp; Attendance Records</a:t>
       </a:r>
     </a:p>
   </a:txBody>
@@ -9189,7 +9342,8 @@
           <a:latin typeface="Microsoft YaHei"/>
           <a:ea typeface="Microsoft YaHei"/>
         </a:rPr>
-        <a:t>培训现场照片/视频记录</a:t>
+        <a:t>培训现场照片/视频记录
+Training Site Photo/Video Documentation</a:t>
       </a:r>
     </a:p>
   </a:txBody>
@@ -9428,7 +9582,8 @@
       <a:r><a:rPr lang="zh-CN" sz="2400" b="1">
         <a:solidFill><a:srgbClr val="1B5E20"/></a:solidFill>
         <a:latin typeface="Microsoft YaHei"/><a:ea typeface="Microsoft YaHei"/>
-      </a:rPr><a:t>模块五：培训考核与认证</a:t></a:r>
+      </a:rPr><a:t>模块五：培训考核与认证
+Module 5: Training Assessment &amp; Certification</a:t></a:r>
     </a:p>
   </p:txBody>
 </p:sp>
@@ -9446,7 +9601,7 @@
       <a:r><a:rPr lang="zh-CN" sz="950">
         <a:solidFill><a:srgbClr val="2E7D32"/></a:solidFill>
         <a:latin typeface="Microsoft YaHei"/><a:ea typeface="Microsoft YaHei"/>
-      </a:rPr><a:t>TM=集团培训经理 | TS=项目培训主管 | TR=一线培训师 | TC=培训文员 | HR=HR培训专员 | TL=生产班组长 | PM=项目经理 | MD=制造总监 | QA=质量部门</a:t></a:r>
+      </a:rPr><a:t>TM=集团培训经理(Training Manager) | TS=项目培训主管(Training Supervisor) | TR=一线培训师(Trainer) | TC=培训文员(Training Clerk) | HR=HR培训专员(HR Specialist) | TL=生产班组长(Team Leader) | PM=项目经理(Project Manager) | MD=制造总监(Manufacturing Director) | QA=质量部门(Quality Dept)</a:t></a:r>
     </a:p>
   </p:txBody>
 </p:sp>
@@ -9464,7 +9619,7 @@
       <a:r><a:rPr lang="zh-CN" sz="900" b="1">
         <a:solidFill><a:srgbClr val="1B5E20"/></a:solidFill>
         <a:latin typeface="Microsoft YaHei"/><a:ea typeface="Microsoft YaHei"/>
-      </a:rPr><a:t>R=负责执行(绿)  A=最终审批(红)  C=被咨询(蓝)  I=被通知(灰)</a:t></a:r>
+      </a:rPr><a:t>R=负责执行/Responsible(Green)  A=最终审批/Accountable(Red)  C=被咨询/Consulted(Blue)  I=被通知/Informed(Gray)</a:t></a:r>
     </a:p>
   </p:txBody>
 </p:sp><p:graphicFrame>
@@ -9508,7 +9663,8 @@
           <a:latin typeface="Microsoft YaHei"/>
           <a:ea typeface="Microsoft YaHei"/>
         </a:rPr>
-        <a:t>#</a:t>
+        <a:t>#
+No.</a:t>
       </a:r>
     </a:p>
   </a:txBody>
@@ -9528,7 +9684,8 @@
           <a:latin typeface="Microsoft YaHei"/>
           <a:ea typeface="Microsoft YaHei"/>
         </a:rPr>
-        <a:t>流程环节</a:t>
+        <a:t>流程环节
+Process Step</a:t>
       </a:r>
     </a:p>
   </a:txBody>
@@ -9548,7 +9705,9 @@
           <a:latin typeface="Microsoft YaHei"/>
           <a:ea typeface="Microsoft YaHei"/>
         </a:rPr>
-        <a:t>TM</a:t>
+        <a:t>TM
+Training
+Manager</a:t>
       </a:r>
     </a:p>
   </a:txBody>
@@ -9568,7 +9727,9 @@
           <a:latin typeface="Microsoft YaHei"/>
           <a:ea typeface="Microsoft YaHei"/>
         </a:rPr>
-        <a:t>TS</a:t>
+        <a:t>TS
+Training
+Supervisor</a:t>
       </a:r>
     </a:p>
   </a:txBody>
@@ -9588,7 +9749,8 @@
           <a:latin typeface="Microsoft YaHei"/>
           <a:ea typeface="Microsoft YaHei"/>
         </a:rPr>
-        <a:t>TR</a:t>
+        <a:t>TR
+Trainer</a:t>
       </a:r>
     </a:p>
   </a:txBody>
@@ -9608,7 +9770,9 @@
           <a:latin typeface="Microsoft YaHei"/>
           <a:ea typeface="Microsoft YaHei"/>
         </a:rPr>
-        <a:t>TC</a:t>
+        <a:t>TC
+Training
+Clerk</a:t>
       </a:r>
     </a:p>
   </a:txBody>
@@ -9628,7 +9792,9 @@
           <a:latin typeface="Microsoft YaHei"/>
           <a:ea typeface="Microsoft YaHei"/>
         </a:rPr>
-        <a:t>HR</a:t>
+        <a:t>HR
+HR
+Specialist</a:t>
       </a:r>
     </a:p>
   </a:txBody>
@@ -9648,7 +9814,9 @@
           <a:latin typeface="Microsoft YaHei"/>
           <a:ea typeface="Microsoft YaHei"/>
         </a:rPr>
-        <a:t>TL</a:t>
+        <a:t>TL
+Team
+Leader</a:t>
       </a:r>
     </a:p>
   </a:txBody>
@@ -9668,7 +9836,9 @@
           <a:latin typeface="Microsoft YaHei"/>
           <a:ea typeface="Microsoft YaHei"/>
         </a:rPr>
-        <a:t>PM</a:t>
+        <a:t>PM
+Project
+Manager</a:t>
       </a:r>
     </a:p>
   </a:txBody>
@@ -9688,7 +9858,9 @@
           <a:latin typeface="Microsoft YaHei"/>
           <a:ea typeface="Microsoft YaHei"/>
         </a:rPr>
-        <a:t>MD</a:t>
+        <a:t>MD
+Mfg
+Director</a:t>
       </a:r>
     </a:p>
   </a:txBody>
@@ -9708,7 +9880,9 @@
           <a:latin typeface="Microsoft YaHei"/>
           <a:ea typeface="Microsoft YaHei"/>
         </a:rPr>
-        <a:t>QA</a:t>
+        <a:t>QA
+Quality
+Dept</a:t>
       </a:r>
     </a:p>
   </a:txBody>
@@ -9748,7 +9922,8 @@
           <a:latin typeface="Microsoft YaHei"/>
           <a:ea typeface="Microsoft YaHei"/>
         </a:rPr>
-        <a:t>理论考试出题与组织</a:t>
+        <a:t>理论考试出题与组织
+Theory Exam Question Development &amp; Administration</a:t>
       </a:r>
     </a:p>
   </a:txBody>
@@ -9968,7 +10143,8 @@
           <a:latin typeface="Microsoft YaHei"/>
           <a:ea typeface="Microsoft YaHei"/>
         </a:rPr>
-        <a:t>理论考试成绩录入与存档</a:t>
+        <a:t>理论考试成绩录入与存档
+Theory Exam Score Entry &amp; Archiving</a:t>
       </a:r>
     </a:p>
   </a:txBody>
@@ -10188,7 +10364,8 @@
           <a:latin typeface="Microsoft YaHei"/>
           <a:ea typeface="Microsoft YaHei"/>
         </a:rPr>
-        <a:t>实操考核安排与执行</a:t>
+        <a:t>实操考核安排与执行
+Practical Assessment Arrangement &amp; Execution</a:t>
       </a:r>
     </a:p>
   </a:txBody>
@@ -10408,7 +10585,8 @@
           <a:latin typeface="Microsoft YaHei"/>
           <a:ea typeface="Microsoft YaHei"/>
         </a:rPr>
-        <a:t>实操考核评分记录</a:t>
+        <a:t>实操考核评分记录
+Practical Assessment Scoring Records</a:t>
       </a:r>
     </a:p>
   </a:txBody>
@@ -10628,7 +10806,8 @@
           <a:latin typeface="Microsoft YaHei"/>
           <a:ea typeface="Microsoft YaHei"/>
         </a:rPr>
-        <a:t>技能等级评定(L0-L3)</a:t>
+        <a:t>技能等级评定(L0-L3)
+Skill Level Assessment (L0-L3)</a:t>
       </a:r>
     </a:p>
   </a:txBody>
@@ -10848,7 +11027,8 @@
           <a:latin typeface="Microsoft YaHei"/>
           <a:ea typeface="Microsoft YaHei"/>
         </a:rPr>
-        <a:t>上岗资格证发放/吊销</a:t>
+        <a:t>上岗资格证发放/吊销
+Work Qualification Certificate Issuance/Revocation</a:t>
       </a:r>
     </a:p>
   </a:txBody>
@@ -11068,7 +11248,8 @@
           <a:latin typeface="Microsoft YaHei"/>
           <a:ea typeface="Microsoft YaHei"/>
         </a:rPr>
-        <a:t>师徒协议签订与跟踪</a:t>
+        <a:t>师徒协议签订与跟踪
+Mentorship Agreement Signing &amp; Tracking</a:t>
       </a:r>
     </a:p>
   </a:txBody>
@@ -11288,7 +11469,8 @@
           <a:latin typeface="Microsoft YaHei"/>
           <a:ea typeface="Microsoft YaHei"/>
         </a:rPr>
-        <a:t>不合格员工复训安排</a:t>
+        <a:t>不合格员工复训安排
+Retraining Arrangement for Non-qualified Employees</a:t>
       </a:r>
     </a:p>
   </a:txBody>
@@ -11527,7 +11709,8 @@
       <a:r><a:rPr lang="zh-CN" sz="2400" b="1">
         <a:solidFill><a:srgbClr val="1B5E20"/></a:solidFill>
         <a:latin typeface="Microsoft YaHei"/><a:ea typeface="Microsoft YaHei"/>
-      </a:rPr><a:t>模块六：技能矩阵管理</a:t></a:r>
+      </a:rPr><a:t>模块六：技能矩阵管理
+Module 6: Skills Matrix Management</a:t></a:r>
     </a:p>
   </p:txBody>
 </p:sp>
@@ -11545,7 +11728,7 @@
       <a:r><a:rPr lang="zh-CN" sz="950">
         <a:solidFill><a:srgbClr val="2E7D32"/></a:solidFill>
         <a:latin typeface="Microsoft YaHei"/><a:ea typeface="Microsoft YaHei"/>
-      </a:rPr><a:t>TM=集团培训经理 | TS=项目培训主管 | TR=一线培训师 | TC=培训文员 | HR=HR培训专员 | TL=生产班组长 | PM=项目经理 | MD=制造总监 | QA=质量部门</a:t></a:r>
+      </a:rPr><a:t>TM=集团培训经理(Training Manager) | TS=项目培训主管(Training Supervisor) | TR=一线培训师(Trainer) | TC=培训文员(Training Clerk) | HR=HR培训专员(HR Specialist) | TL=生产班组长(Team Leader) | PM=项目经理(Project Manager) | MD=制造总监(Manufacturing Director) | QA=质量部门(Quality Dept)</a:t></a:r>
     </a:p>
   </p:txBody>
 </p:sp>
@@ -11563,7 +11746,7 @@
       <a:r><a:rPr lang="zh-CN" sz="900" b="1">
         <a:solidFill><a:srgbClr val="1B5E20"/></a:solidFill>
         <a:latin typeface="Microsoft YaHei"/><a:ea typeface="Microsoft YaHei"/>
-      </a:rPr><a:t>R=负责执行(绿)  A=最终审批(红)  C=被咨询(蓝)  I=被通知(灰)</a:t></a:r>
+      </a:rPr><a:t>R=负责执行/Responsible(Green)  A=最终审批/Accountable(Red)  C=被咨询/Consulted(Blue)  I=被通知/Informed(Gray)</a:t></a:r>
     </a:p>
   </p:txBody>
 </p:sp><p:graphicFrame>
@@ -11607,7 +11790,8 @@
           <a:latin typeface="Microsoft YaHei"/>
           <a:ea typeface="Microsoft YaHei"/>
         </a:rPr>
-        <a:t>#</a:t>
+        <a:t>#
+No.</a:t>
       </a:r>
     </a:p>
   </a:txBody>
@@ -11627,7 +11811,8 @@
           <a:latin typeface="Microsoft YaHei"/>
           <a:ea typeface="Microsoft YaHei"/>
         </a:rPr>
-        <a:t>流程环节</a:t>
+        <a:t>流程环节
+Process Step</a:t>
       </a:r>
     </a:p>
   </a:txBody>
@@ -11647,7 +11832,9 @@
           <a:latin typeface="Microsoft YaHei"/>
           <a:ea typeface="Microsoft YaHei"/>
         </a:rPr>
-        <a:t>TM</a:t>
+        <a:t>TM
+Training
+Manager</a:t>
       </a:r>
     </a:p>
   </a:txBody>
@@ -11667,7 +11854,9 @@
           <a:latin typeface="Microsoft YaHei"/>
           <a:ea typeface="Microsoft YaHei"/>
         </a:rPr>
-        <a:t>TS</a:t>
+        <a:t>TS
+Training
+Supervisor</a:t>
       </a:r>
     </a:p>
   </a:txBody>
@@ -11687,7 +11876,8 @@
           <a:latin typeface="Microsoft YaHei"/>
           <a:ea typeface="Microsoft YaHei"/>
         </a:rPr>
-        <a:t>TR</a:t>
+        <a:t>TR
+Trainer</a:t>
       </a:r>
     </a:p>
   </a:txBody>
@@ -11707,7 +11897,9 @@
           <a:latin typeface="Microsoft YaHei"/>
           <a:ea typeface="Microsoft YaHei"/>
         </a:rPr>
-        <a:t>TC</a:t>
+        <a:t>TC
+Training
+Clerk</a:t>
       </a:r>
     </a:p>
   </a:txBody>
@@ -11727,7 +11919,9 @@
           <a:latin typeface="Microsoft YaHei"/>
           <a:ea typeface="Microsoft YaHei"/>
         </a:rPr>
-        <a:t>HR</a:t>
+        <a:t>HR
+HR
+Specialist</a:t>
       </a:r>
     </a:p>
   </a:txBody>
@@ -11747,7 +11941,9 @@
           <a:latin typeface="Microsoft YaHei"/>
           <a:ea typeface="Microsoft YaHei"/>
         </a:rPr>
-        <a:t>TL</a:t>
+        <a:t>TL
+Team
+Leader</a:t>
       </a:r>
     </a:p>
   </a:txBody>
@@ -11767,7 +11963,9 @@
           <a:latin typeface="Microsoft YaHei"/>
           <a:ea typeface="Microsoft YaHei"/>
         </a:rPr>
-        <a:t>PM</a:t>
+        <a:t>PM
+Project
+Manager</a:t>
       </a:r>
     </a:p>
   </a:txBody>
@@ -11787,7 +11985,9 @@
           <a:latin typeface="Microsoft YaHei"/>
           <a:ea typeface="Microsoft YaHei"/>
         </a:rPr>
-        <a:t>MD</a:t>
+        <a:t>MD
+Mfg
+Director</a:t>
       </a:r>
     </a:p>
   </a:txBody>
@@ -11807,7 +12007,9 @@
           <a:latin typeface="Microsoft YaHei"/>
           <a:ea typeface="Microsoft YaHei"/>
         </a:rPr>
-        <a:t>QA</a:t>
+        <a:t>QA
+Quality
+Dept</a:t>
       </a:r>
     </a:p>
   </a:txBody>
@@ -11847,7 +12049,8 @@
           <a:latin typeface="Microsoft YaHei"/>
           <a:ea typeface="Microsoft YaHei"/>
         </a:rPr>
-        <a:t>技能矩阵模板设计与维护</a:t>
+        <a:t>技能矩阵模板设计与维护
+Skills Matrix Template Design &amp; Maintenance</a:t>
       </a:r>
     </a:p>
   </a:txBody>
@@ -12067,7 +12270,8 @@
           <a:latin typeface="Microsoft YaHei"/>
           <a:ea typeface="Microsoft YaHei"/>
         </a:rPr>
-        <a:t>员工技能数据采集与更新</a:t>
+        <a:t>员工技能数据采集与更新
+Employee Skills Data Collection &amp; Update</a:t>
       </a:r>
     </a:p>
   </a:txBody>
@@ -12287,7 +12491,8 @@
           <a:latin typeface="Microsoft YaHei"/>
           <a:ea typeface="Microsoft YaHei"/>
         </a:rPr>
-        <a:t>技能矩阵可视化更新</a:t>
+        <a:t>技能矩阵可视化更新
+Skills Matrix Visual Update</a:t>
       </a:r>
     </a:p>
   </a:txBody>
@@ -12507,7 +12712,8 @@
           <a:latin typeface="Microsoft YaHei"/>
           <a:ea typeface="Microsoft YaHei"/>
         </a:rPr>
-        <a:t>技能矩阵月度审核与异常处理</a:t>
+        <a:t>技能矩阵月度审核与异常处理
+Skills Matrix Monthly Review &amp; Exception Handling</a:t>
       </a:r>
     </a:p>
   </a:txBody>
@@ -12727,7 +12933,8 @@
           <a:latin typeface="Microsoft YaHei"/>
           <a:ea typeface="Microsoft YaHei"/>
         </a:rPr>
-        <a:t>跨项目技能矩阵对齐(VT vs NX)</a:t>
+        <a:t>跨项目技能矩阵对齐(VT vs NX)
+Cross-project Skills Matrix Alignment (VT vs NX)</a:t>
       </a:r>
     </a:p>
   </a:txBody>
@@ -12966,7 +13173,8 @@
       <a:r><a:rPr lang="zh-CN" sz="2400" b="1">
         <a:solidFill><a:srgbClr val="1B5E20"/></a:solidFill>
         <a:latin typeface="Microsoft YaHei"/><a:ea typeface="Microsoft YaHei"/>
-      </a:rPr><a:t>模块七：培训师管理</a:t></a:r>
+      </a:rPr><a:t>模块七：培训师管理
+Module 7: Trainer Management</a:t></a:r>
     </a:p>
   </p:txBody>
 </p:sp>
@@ -12984,7 +13192,7 @@
       <a:r><a:rPr lang="zh-CN" sz="950">
         <a:solidFill><a:srgbClr val="2E7D32"/></a:solidFill>
         <a:latin typeface="Microsoft YaHei"/><a:ea typeface="Microsoft YaHei"/>
-      </a:rPr><a:t>TM=集团培训经理 | TS=项目培训主管 | TR=一线培训师 | TC=培训文员 | HR=HR培训专员 | TL=生产班组长 | PM=项目经理 | MD=制造总监 | QA=质量部门</a:t></a:r>
+      </a:rPr><a:t>TM=集团培训经理(Training Manager) | TS=项目培训主管(Training Supervisor) | TR=一线培训师(Trainer) | TC=培训文员(Training Clerk) | HR=HR培训专员(HR Specialist) | TL=生产班组长(Team Leader) | PM=项目经理(Project Manager) | MD=制造总监(Manufacturing Director) | QA=质量部门(Quality Dept)</a:t></a:r>
     </a:p>
   </p:txBody>
 </p:sp>
@@ -13002,7 +13210,7 @@
       <a:r><a:rPr lang="zh-CN" sz="900" b="1">
         <a:solidFill><a:srgbClr val="1B5E20"/></a:solidFill>
         <a:latin typeface="Microsoft YaHei"/><a:ea typeface="Microsoft YaHei"/>
-      </a:rPr><a:t>R=负责执行(绿)  A=最终审批(红)  C=被咨询(蓝)  I=被通知(灰)</a:t></a:r>
+      </a:rPr><a:t>R=负责执行/Responsible(Green)  A=最终审批/Accountable(Red)  C=被咨询/Consulted(Blue)  I=被通知/Informed(Gray)</a:t></a:r>
     </a:p>
   </p:txBody>
 </p:sp><p:graphicFrame>
@@ -13046,7 +13254,8 @@
           <a:latin typeface="Microsoft YaHei"/>
           <a:ea typeface="Microsoft YaHei"/>
         </a:rPr>
-        <a:t>#</a:t>
+        <a:t>#
+No.</a:t>
       </a:r>
     </a:p>
   </a:txBody>
@@ -13066,7 +13275,8 @@
           <a:latin typeface="Microsoft YaHei"/>
           <a:ea typeface="Microsoft YaHei"/>
         </a:rPr>
-        <a:t>流程环节</a:t>
+        <a:t>流程环节
+Process Step</a:t>
       </a:r>
     </a:p>
   </a:txBody>
@@ -13086,7 +13296,9 @@
           <a:latin typeface="Microsoft YaHei"/>
           <a:ea typeface="Microsoft YaHei"/>
         </a:rPr>
-        <a:t>TM</a:t>
+        <a:t>TM
+Training
+Manager</a:t>
       </a:r>
     </a:p>
   </a:txBody>
@@ -13106,7 +13318,9 @@
           <a:latin typeface="Microsoft YaHei"/>
           <a:ea typeface="Microsoft YaHei"/>
         </a:rPr>
-        <a:t>TS</a:t>
+        <a:t>TS
+Training
+Supervisor</a:t>
       </a:r>
     </a:p>
   </a:txBody>
@@ -13126,7 +13340,8 @@
           <a:latin typeface="Microsoft YaHei"/>
           <a:ea typeface="Microsoft YaHei"/>
         </a:rPr>
-        <a:t>TR</a:t>
+        <a:t>TR
+Trainer</a:t>
       </a:r>
     </a:p>
   </a:txBody>
@@ -13146,7 +13361,9 @@
           <a:latin typeface="Microsoft YaHei"/>
           <a:ea typeface="Microsoft YaHei"/>
         </a:rPr>
-        <a:t>TC</a:t>
+        <a:t>TC
+Training
+Clerk</a:t>
       </a:r>
     </a:p>
   </a:txBody>
@@ -13166,7 +13383,9 @@
           <a:latin typeface="Microsoft YaHei"/>
           <a:ea typeface="Microsoft YaHei"/>
         </a:rPr>
-        <a:t>HR</a:t>
+        <a:t>HR
+HR
+Specialist</a:t>
       </a:r>
     </a:p>
   </a:txBody>
@@ -13186,7 +13405,9 @@
           <a:latin typeface="Microsoft YaHei"/>
           <a:ea typeface="Microsoft YaHei"/>
         </a:rPr>
-        <a:t>TL</a:t>
+        <a:t>TL
+Team
+Leader</a:t>
       </a:r>
     </a:p>
   </a:txBody>
@@ -13206,7 +13427,9 @@
           <a:latin typeface="Microsoft YaHei"/>
           <a:ea typeface="Microsoft YaHei"/>
         </a:rPr>
-        <a:t>PM</a:t>
+        <a:t>PM
+Project
+Manager</a:t>
       </a:r>
     </a:p>
   </a:txBody>
@@ -13226,7 +13449,9 @@
           <a:latin typeface="Microsoft YaHei"/>
           <a:ea typeface="Microsoft YaHei"/>
         </a:rPr>
-        <a:t>MD</a:t>
+        <a:t>MD
+Mfg
+Director</a:t>
       </a:r>
     </a:p>
   </a:txBody>
@@ -13246,7 +13471,9 @@
           <a:latin typeface="Microsoft YaHei"/>
           <a:ea typeface="Microsoft YaHei"/>
         </a:rPr>
-        <a:t>QA</a:t>
+        <a:t>QA
+Quality
+Dept</a:t>
       </a:r>
     </a:p>
   </a:txBody>
@@ -13286,7 +13513,8 @@
           <a:latin typeface="Microsoft YaHei"/>
           <a:ea typeface="Microsoft YaHei"/>
         </a:rPr>
-        <a:t>培训师选拔与资质评估</a:t>
+        <a:t>培训师选拔与资质评估
+Trainer Selection &amp; Qualification Assessment</a:t>
       </a:r>
     </a:p>
   </a:txBody>
@@ -13506,7 +13734,8 @@
           <a:latin typeface="Microsoft YaHei"/>
           <a:ea typeface="Microsoft YaHei"/>
         </a:rPr>
-        <a:t>培训师技能矩阵维护</a:t>
+        <a:t>培训师技能矩阵维护
+Trainer Skills Matrix Maintenance</a:t>
       </a:r>
     </a:p>
   </a:txBody>
@@ -13726,7 +13955,8 @@
           <a:latin typeface="Microsoft YaHei"/>
           <a:ea typeface="Microsoft YaHei"/>
         </a:rPr>
-        <a:t>培训师培训能力评估(TTT)</a:t>
+        <a:t>培训师培训能力评估(TTT)
+Trainer Training Competency Assessment (TTT)</a:t>
       </a:r>
     </a:p>
   </a:txBody>
@@ -13946,7 +14176,8 @@
           <a:latin typeface="Microsoft YaHei"/>
           <a:ea typeface="Microsoft YaHei"/>
         </a:rPr>
-        <a:t>培训师绩效考核</a:t>
+        <a:t>培训师绩效考核
+Trainer Performance Evaluation</a:t>
       </a:r>
     </a:p>
   </a:txBody>
@@ -14166,7 +14397,8 @@
           <a:latin typeface="Microsoft YaHei"/>
           <a:ea typeface="Microsoft YaHei"/>
         </a:rPr>
-        <a:t>培训师跨班次调配</a:t>
+        <a:t>培训师跨班次调配
+Trainer Cross-shift Allocation</a:t>
       </a:r>
     </a:p>
   </a:txBody>
@@ -14386,7 +14618,8 @@
           <a:latin typeface="Microsoft YaHei"/>
           <a:ea typeface="Microsoft YaHei"/>
         </a:rPr>
-        <a:t>培训师资质档案维护</a:t>
+        <a:t>培训师资质档案维护
+Trainer Qualification Archive Maintenance</a:t>
       </a:r>
     </a:p>
   </a:txBody>
@@ -14625,7 +14858,8 @@
       <a:r><a:rPr lang="zh-CN" sz="2400" b="1">
         <a:solidFill><a:srgbClr val="1B5E20"/></a:solidFill>
         <a:latin typeface="Microsoft YaHei"/><a:ea typeface="Microsoft YaHei"/>
-      </a:rPr><a:t>模块八：培训记录与档案管理</a:t></a:r>
+      </a:rPr><a:t>模块八：培训记录与档案管理
+Module 8: Training Records &amp; Archives Management</a:t></a:r>
     </a:p>
   </p:txBody>
 </p:sp>
@@ -14643,7 +14877,7 @@
       <a:r><a:rPr lang="zh-CN" sz="950">
         <a:solidFill><a:srgbClr val="2E7D32"/></a:solidFill>
         <a:latin typeface="Microsoft YaHei"/><a:ea typeface="Microsoft YaHei"/>
-      </a:rPr><a:t>TM=集团培训经理 | TS=项目培训主管 | TR=一线培训师 | TC=培训文员 | HR=HR培训专员 | TL=生产班组长 | PM=项目经理 | MD=制造总监 | QA=质量部门</a:t></a:r>
+      </a:rPr><a:t>TM=集团培训经理(Training Manager) | TS=项目培训主管(Training Supervisor) | TR=一线培训师(Trainer) | TC=培训文员(Training Clerk) | HR=HR培训专员(HR Specialist) | TL=生产班组长(Team Leader) | PM=项目经理(Project Manager) | MD=制造总监(Manufacturing Director) | QA=质量部门(Quality Dept)</a:t></a:r>
     </a:p>
   </p:txBody>
 </p:sp>
@@ -14661,7 +14895,7 @@
       <a:r><a:rPr lang="zh-CN" sz="900" b="1">
         <a:solidFill><a:srgbClr val="1B5E20"/></a:solidFill>
         <a:latin typeface="Microsoft YaHei"/><a:ea typeface="Microsoft YaHei"/>
-      </a:rPr><a:t>R=负责执行(绿)  A=最终审批(红)  C=被咨询(蓝)  I=被通知(灰)</a:t></a:r>
+      </a:rPr><a:t>R=负责执行/Responsible(Green)  A=最终审批/Accountable(Red)  C=被咨询/Consulted(Blue)  I=被通知/Informed(Gray)</a:t></a:r>
     </a:p>
   </p:txBody>
 </p:sp><p:graphicFrame>
@@ -14705,7 +14939,8 @@
           <a:latin typeface="Microsoft YaHei"/>
           <a:ea typeface="Microsoft YaHei"/>
         </a:rPr>
-        <a:t>#</a:t>
+        <a:t>#
+No.</a:t>
       </a:r>
     </a:p>
   </a:txBody>
@@ -14725,7 +14960,8 @@
           <a:latin typeface="Microsoft YaHei"/>
           <a:ea typeface="Microsoft YaHei"/>
         </a:rPr>
-        <a:t>流程环节</a:t>
+        <a:t>流程环节
+Process Step</a:t>
       </a:r>
     </a:p>
   </a:txBody>
@@ -14745,7 +14981,9 @@
           <a:latin typeface="Microsoft YaHei"/>
           <a:ea typeface="Microsoft YaHei"/>
         </a:rPr>
-        <a:t>TM</a:t>
+        <a:t>TM
+Training
+Manager</a:t>
       </a:r>
     </a:p>
   </a:txBody>
@@ -14765,7 +15003,9 @@
           <a:latin typeface="Microsoft YaHei"/>
           <a:ea typeface="Microsoft YaHei"/>
         </a:rPr>
-        <a:t>TS</a:t>
+        <a:t>TS
+Training
+Supervisor</a:t>
       </a:r>
     </a:p>
   </a:txBody>
@@ -14785,7 +15025,8 @@
           <a:latin typeface="Microsoft YaHei"/>
           <a:ea typeface="Microsoft YaHei"/>
         </a:rPr>
-        <a:t>TR</a:t>
+        <a:t>TR
+Trainer</a:t>
       </a:r>
     </a:p>
   </a:txBody>
@@ -14805,7 +15046,9 @@
           <a:latin typeface="Microsoft YaHei"/>
           <a:ea typeface="Microsoft YaHei"/>
         </a:rPr>
-        <a:t>TC</a:t>
+        <a:t>TC
+Training
+Clerk</a:t>
       </a:r>
     </a:p>
   </a:txBody>
@@ -14825,7 +15068,9 @@
           <a:latin typeface="Microsoft YaHei"/>
           <a:ea typeface="Microsoft YaHei"/>
         </a:rPr>
-        <a:t>HR</a:t>
+        <a:t>HR
+HR
+Specialist</a:t>
       </a:r>
     </a:p>
   </a:txBody>
@@ -14845,7 +15090,9 @@
           <a:latin typeface="Microsoft YaHei"/>
           <a:ea typeface="Microsoft YaHei"/>
         </a:rPr>
-        <a:t>TL</a:t>
+        <a:t>TL
+Team
+Leader</a:t>
       </a:r>
     </a:p>
   </a:txBody>
@@ -14865,7 +15112,9 @@
           <a:latin typeface="Microsoft YaHei"/>
           <a:ea typeface="Microsoft YaHei"/>
         </a:rPr>
-        <a:t>PM</a:t>
+        <a:t>PM
+Project
+Manager</a:t>
       </a:r>
     </a:p>
   </a:txBody>
@@ -14885,7 +15134,9 @@
           <a:latin typeface="Microsoft YaHei"/>
           <a:ea typeface="Microsoft YaHei"/>
         </a:rPr>
-        <a:t>MD</a:t>
+        <a:t>MD
+Mfg
+Director</a:t>
       </a:r>
     </a:p>
   </a:txBody>
@@ -14905,7 +15156,9 @@
           <a:latin typeface="Microsoft YaHei"/>
           <a:ea typeface="Microsoft YaHei"/>
         </a:rPr>
-        <a:t>QA</a:t>
+        <a:t>QA
+Quality
+Dept</a:t>
       </a:r>
     </a:p>
   </a:txBody>
@@ -14945,7 +15198,8 @@
           <a:latin typeface="Microsoft YaHei"/>
           <a:ea typeface="Microsoft YaHei"/>
         </a:rPr>
-        <a:t>培训记录收集</a:t>
+        <a:t>培训记录收集
+Training Records Collection</a:t>
       </a:r>
     </a:p>
   </a:txBody>
@@ -15165,7 +15419,8 @@
           <a:latin typeface="Microsoft YaHei"/>
           <a:ea typeface="Microsoft YaHei"/>
         </a:rPr>
-        <a:t>培训记录完整性检查</a:t>
+        <a:t>培训记录完整性检查
+Training Records Completeness Check</a:t>
       </a:r>
     </a:p>
   </a:txBody>
@@ -15385,7 +15640,8 @@
           <a:latin typeface="Microsoft YaHei"/>
           <a:ea typeface="Microsoft YaHei"/>
         </a:rPr>
-        <a:t>培训记录归档(一人一档)</a:t>
+        <a:t>培训记录归档(一人一档)
+Training Records Archiving (One Person One File)</a:t>
       </a:r>
     </a:p>
   </a:txBody>
@@ -15605,7 +15861,8 @@
           <a:latin typeface="Microsoft YaHei"/>
           <a:ea typeface="Microsoft YaHei"/>
         </a:rPr>
-        <a:t>培训记录电子化/系统录入</a:t>
+        <a:t>培训记录电子化/系统录入
+Training Records Digitization/System Entry</a:t>
       </a:r>
     </a:p>
   </a:txBody>
@@ -15825,7 +16082,8 @@
           <a:latin typeface="Microsoft YaHei"/>
           <a:ea typeface="Microsoft YaHei"/>
         </a:rPr>
-        <a:t>纸质档案管理</a:t>
+        <a:t>纸质档案管理
+Paper Archive Management</a:t>
       </a:r>
     </a:p>
   </a:txBody>
@@ -16045,7 +16303,8 @@
           <a:latin typeface="Microsoft YaHei"/>
           <a:ea typeface="Microsoft YaHei"/>
         </a:rPr>
-        <a:t>培训记录定期抽查与审计</a:t>
+        <a:t>培训记录定期抽查与审计
+Training Records Periodic Sampling &amp; Audit</a:t>
       </a:r>
     </a:p>
   </a:txBody>

</xml_diff>